<commit_message>
updated date in ppt slides
</commit_message>
<xml_diff>
--- a/resources/DAY2_DESeq2.pptx
+++ b/resources/DAY2_DESeq2.pptx
@@ -207,7 +207,7 @@
           <a:p>
             <a:fld id="{95A5B5C2-D20E-D94C-AE13-EC813CCA806E}" type="datetimeFigureOut">
               <a:rPr lang="en-NL" smtClean="0"/>
-              <a:t>01/04/2026</a:t>
+              <a:t>15/04/2026</a:t>
             </a:fld>
             <a:endParaRPr lang="en-NL"/>
           </a:p>
@@ -624,7 +624,7 @@
           <a:p>
             <a:fld id="{C343B324-12C9-834D-ABF6-004FC7226AF0}" type="datetimeFigureOut">
               <a:rPr lang="en-NL" smtClean="0"/>
-              <a:t>01/04/2026</a:t>
+              <a:t>15/04/2026</a:t>
             </a:fld>
             <a:endParaRPr lang="en-NL"/>
           </a:p>
@@ -824,7 +824,7 @@
           <a:p>
             <a:fld id="{C343B324-12C9-834D-ABF6-004FC7226AF0}" type="datetimeFigureOut">
               <a:rPr lang="en-NL" smtClean="0"/>
-              <a:t>01/04/2026</a:t>
+              <a:t>15/04/2026</a:t>
             </a:fld>
             <a:endParaRPr lang="en-NL"/>
           </a:p>
@@ -1034,7 +1034,7 @@
           <a:p>
             <a:fld id="{C343B324-12C9-834D-ABF6-004FC7226AF0}" type="datetimeFigureOut">
               <a:rPr lang="en-NL" smtClean="0"/>
-              <a:t>01/04/2026</a:t>
+              <a:t>15/04/2026</a:t>
             </a:fld>
             <a:endParaRPr lang="en-NL"/>
           </a:p>
@@ -1234,7 +1234,7 @@
           <a:p>
             <a:fld id="{C343B324-12C9-834D-ABF6-004FC7226AF0}" type="datetimeFigureOut">
               <a:rPr lang="en-NL" smtClean="0"/>
-              <a:t>01/04/2026</a:t>
+              <a:t>15/04/2026</a:t>
             </a:fld>
             <a:endParaRPr lang="en-NL"/>
           </a:p>
@@ -1510,7 +1510,7 @@
           <a:p>
             <a:fld id="{C343B324-12C9-834D-ABF6-004FC7226AF0}" type="datetimeFigureOut">
               <a:rPr lang="en-NL" smtClean="0"/>
-              <a:t>01/04/2026</a:t>
+              <a:t>15/04/2026</a:t>
             </a:fld>
             <a:endParaRPr lang="en-NL"/>
           </a:p>
@@ -1778,7 +1778,7 @@
           <a:p>
             <a:fld id="{C343B324-12C9-834D-ABF6-004FC7226AF0}" type="datetimeFigureOut">
               <a:rPr lang="en-NL" smtClean="0"/>
-              <a:t>01/04/2026</a:t>
+              <a:t>15/04/2026</a:t>
             </a:fld>
             <a:endParaRPr lang="en-NL"/>
           </a:p>
@@ -2193,7 +2193,7 @@
           <a:p>
             <a:fld id="{C343B324-12C9-834D-ABF6-004FC7226AF0}" type="datetimeFigureOut">
               <a:rPr lang="en-NL" smtClean="0"/>
-              <a:t>01/04/2026</a:t>
+              <a:t>15/04/2026</a:t>
             </a:fld>
             <a:endParaRPr lang="en-NL"/>
           </a:p>
@@ -2335,7 +2335,7 @@
           <a:p>
             <a:fld id="{C343B324-12C9-834D-ABF6-004FC7226AF0}" type="datetimeFigureOut">
               <a:rPr lang="en-NL" smtClean="0"/>
-              <a:t>01/04/2026</a:t>
+              <a:t>15/04/2026</a:t>
             </a:fld>
             <a:endParaRPr lang="en-NL"/>
           </a:p>
@@ -2448,7 +2448,7 @@
           <a:p>
             <a:fld id="{C343B324-12C9-834D-ABF6-004FC7226AF0}" type="datetimeFigureOut">
               <a:rPr lang="en-NL" smtClean="0"/>
-              <a:t>01/04/2026</a:t>
+              <a:t>15/04/2026</a:t>
             </a:fld>
             <a:endParaRPr lang="en-NL"/>
           </a:p>
@@ -2761,7 +2761,7 @@
           <a:p>
             <a:fld id="{C343B324-12C9-834D-ABF6-004FC7226AF0}" type="datetimeFigureOut">
               <a:rPr lang="en-NL" smtClean="0"/>
-              <a:t>01/04/2026</a:t>
+              <a:t>15/04/2026</a:t>
             </a:fld>
             <a:endParaRPr lang="en-NL"/>
           </a:p>
@@ -3050,7 +3050,7 @@
           <a:p>
             <a:fld id="{C343B324-12C9-834D-ABF6-004FC7226AF0}" type="datetimeFigureOut">
               <a:rPr lang="en-NL" smtClean="0"/>
-              <a:t>01/04/2026</a:t>
+              <a:t>15/04/2026</a:t>
             </a:fld>
             <a:endParaRPr lang="en-NL"/>
           </a:p>
@@ -3293,7 +3293,7 @@
           <a:p>
             <a:fld id="{C343B324-12C9-834D-ABF6-004FC7226AF0}" type="datetimeFigureOut">
               <a:rPr lang="en-NL" smtClean="0"/>
-              <a:t>01/04/2026</a:t>
+              <a:t>15/04/2026</a:t>
             </a:fld>
             <a:endParaRPr lang="en-NL"/>
           </a:p>
@@ -3797,7 +3797,7 @@
                 <a:ea typeface="Helvetica Neue" panose="02000503000000020004" pitchFamily="2" charset="0"/>
                 <a:cs typeface="Helvetica Neue" panose="02000503000000020004" pitchFamily="2" charset="0"/>
               </a:rPr>
-              <a:t>2 &amp; 4 March 2026</a:t>
+              <a:t>13 &amp; 15 April 2026</a:t>
             </a:r>
           </a:p>
         </p:txBody>
@@ -3944,8 +3944,8 @@
         </p:nvSpPr>
         <p:spPr>
           <a:xfrm>
-            <a:off x="838200" y="365125"/>
-            <a:ext cx="10515600" cy="1325563"/>
+            <a:off x="838199" y="365125"/>
+            <a:ext cx="10858995" cy="1325563"/>
           </a:xfrm>
           <a:prstGeom prst="rect">
             <a:avLst/>
@@ -3974,7 +3974,7 @@
           </a:lstStyle>
           <a:p>
             <a:r>
-              <a:rPr lang="nl-NL" dirty="0">
+              <a:rPr lang="nl-NL" sz="3200" dirty="0">
                 <a:latin typeface="Helvetica Neue" panose="02000503000000020004" pitchFamily="2" charset="0"/>
                 <a:ea typeface="Helvetica Neue" panose="02000503000000020004" pitchFamily="2" charset="0"/>
                 <a:cs typeface="Helvetica Neue" panose="02000503000000020004" pitchFamily="2" charset="0"/>
@@ -3982,14 +3982,86 @@
               <a:t>Workshop </a:t>
             </a:r>
             <a:r>
-              <a:rPr lang="nl-NL" dirty="0" err="1">
+              <a:rPr lang="nl-NL" sz="3200" dirty="0" err="1">
                 <a:latin typeface="Helvetica Neue" panose="02000503000000020004" pitchFamily="2" charset="0"/>
                 <a:ea typeface="Helvetica Neue" panose="02000503000000020004" pitchFamily="2" charset="0"/>
                 <a:cs typeface="Helvetica Neue" panose="02000503000000020004" pitchFamily="2" charset="0"/>
               </a:rPr>
               <a:t>logistics</a:t>
             </a:r>
-            <a:endParaRPr lang="en-NL" dirty="0">
+            <a:r>
+              <a:rPr lang="nl-NL" sz="3200" dirty="0">
+                <a:latin typeface="Helvetica Neue" panose="02000503000000020004" pitchFamily="2" charset="0"/>
+                <a:ea typeface="Helvetica Neue" panose="02000503000000020004" pitchFamily="2" charset="0"/>
+                <a:cs typeface="Helvetica Neue" panose="02000503000000020004" pitchFamily="2" charset="0"/>
+              </a:rPr>
+              <a:t>: On </a:t>
+            </a:r>
+            <a:r>
+              <a:rPr lang="nl-NL" sz="3200" dirty="0" err="1">
+                <a:latin typeface="Helvetica Neue" panose="02000503000000020004" pitchFamily="2" charset="0"/>
+                <a:ea typeface="Helvetica Neue" panose="02000503000000020004" pitchFamily="2" charset="0"/>
+                <a:cs typeface="Helvetica Neue" panose="02000503000000020004" pitchFamily="2" charset="0"/>
+              </a:rPr>
+              <a:t>your</a:t>
+            </a:r>
+            <a:r>
+              <a:rPr lang="nl-NL" sz="3200" dirty="0">
+                <a:latin typeface="Helvetica Neue" panose="02000503000000020004" pitchFamily="2" charset="0"/>
+                <a:ea typeface="Helvetica Neue" panose="02000503000000020004" pitchFamily="2" charset="0"/>
+                <a:cs typeface="Helvetica Neue" panose="02000503000000020004" pitchFamily="2" charset="0"/>
+              </a:rPr>
+              <a:t> laptop, </a:t>
+            </a:r>
+            <a:r>
+              <a:rPr lang="nl-NL" sz="3200" dirty="0" err="1">
+                <a:latin typeface="Helvetica Neue" panose="02000503000000020004" pitchFamily="2" charset="0"/>
+                <a:ea typeface="Helvetica Neue" panose="02000503000000020004" pitchFamily="2" charset="0"/>
+                <a:cs typeface="Helvetica Neue" panose="02000503000000020004" pitchFamily="2" charset="0"/>
+              </a:rPr>
+              <a:t>create</a:t>
+            </a:r>
+            <a:r>
+              <a:rPr lang="nl-NL" sz="3200" dirty="0">
+                <a:latin typeface="Helvetica Neue" panose="02000503000000020004" pitchFamily="2" charset="0"/>
+                <a:ea typeface="Helvetica Neue" panose="02000503000000020004" pitchFamily="2" charset="0"/>
+                <a:cs typeface="Helvetica Neue" panose="02000503000000020004" pitchFamily="2" charset="0"/>
+              </a:rPr>
+              <a:t> folder </a:t>
+            </a:r>
+            <a:r>
+              <a:rPr lang="nl-NL" sz="3200" dirty="0" err="1">
+                <a:latin typeface="Helvetica Neue" panose="02000503000000020004" pitchFamily="2" charset="0"/>
+                <a:ea typeface="Helvetica Neue" panose="02000503000000020004" pitchFamily="2" charset="0"/>
+                <a:cs typeface="Helvetica Neue" panose="02000503000000020004" pitchFamily="2" charset="0"/>
+              </a:rPr>
+              <a:t>structure</a:t>
+            </a:r>
+            <a:r>
+              <a:rPr lang="nl-NL" sz="3200" dirty="0">
+                <a:latin typeface="Helvetica Neue" panose="02000503000000020004" pitchFamily="2" charset="0"/>
+                <a:ea typeface="Helvetica Neue" panose="02000503000000020004" pitchFamily="2" charset="0"/>
+                <a:cs typeface="Helvetica Neue" panose="02000503000000020004" pitchFamily="2" charset="0"/>
+              </a:rPr>
+              <a:t> like </a:t>
+            </a:r>
+            <a:r>
+              <a:rPr lang="nl-NL" sz="3200" dirty="0" err="1">
+                <a:latin typeface="Helvetica Neue" panose="02000503000000020004" pitchFamily="2" charset="0"/>
+                <a:ea typeface="Helvetica Neue" panose="02000503000000020004" pitchFamily="2" charset="0"/>
+                <a:cs typeface="Helvetica Neue" panose="02000503000000020004" pitchFamily="2" charset="0"/>
+              </a:rPr>
+              <a:t>this</a:t>
+            </a:r>
+            <a:r>
+              <a:rPr lang="nl-NL" sz="3200" dirty="0">
+                <a:latin typeface="Helvetica Neue" panose="02000503000000020004" pitchFamily="2" charset="0"/>
+                <a:ea typeface="Helvetica Neue" panose="02000503000000020004" pitchFamily="2" charset="0"/>
+                <a:cs typeface="Helvetica Neue" panose="02000503000000020004" pitchFamily="2" charset="0"/>
+              </a:rPr>
+              <a:t>:</a:t>
+            </a:r>
+            <a:endParaRPr lang="en-NL" sz="3200" dirty="0">
               <a:latin typeface="Helvetica Neue" panose="02000503000000020004" pitchFamily="2" charset="0"/>
               <a:ea typeface="Helvetica Neue" panose="02000503000000020004" pitchFamily="2" charset="0"/>
               <a:cs typeface="Helvetica Neue" panose="02000503000000020004" pitchFamily="2" charset="0"/>
@@ -3997,12 +4069,102 @@
           </a:p>
         </p:txBody>
       </p:sp>
-      <p:sp>
-        <p:nvSpPr>
-          <p:cNvPr id="3" name="Content Placeholder 2">
-            <a:extLst>
-              <a:ext uri="{FF2B5EF4-FFF2-40B4-BE49-F238E27FC236}">
-                <a16:creationId xmlns:a16="http://schemas.microsoft.com/office/drawing/2014/main" id="{746C1CE0-9E86-8C82-C2B7-70AA8FF6FDDB}"/>
+      <p:pic>
+        <p:nvPicPr>
+          <p:cNvPr id="4" name="Picture 3">
+            <a:extLst>
+              <a:ext uri="{FF2B5EF4-FFF2-40B4-BE49-F238E27FC236}">
+                <a16:creationId xmlns:a16="http://schemas.microsoft.com/office/drawing/2014/main" id="{92F9D21B-FD6B-7A1B-79B2-1538225B05AF}"/>
+              </a:ext>
+            </a:extLst>
+          </p:cNvPr>
+          <p:cNvPicPr>
+            <a:picLocks noChangeAspect="1"/>
+          </p:cNvPicPr>
+          <p:nvPr/>
+        </p:nvPicPr>
+        <p:blipFill>
+          <a:blip r:embed="rId2"/>
+          <a:stretch>
+            <a:fillRect/>
+          </a:stretch>
+        </p:blipFill>
+        <p:spPr>
+          <a:xfrm>
+            <a:off x="2000670" y="1777257"/>
+            <a:ext cx="8190660" cy="4470157"/>
+          </a:xfrm>
+          <a:prstGeom prst="rect">
+            <a:avLst/>
+          </a:prstGeom>
+        </p:spPr>
+      </p:pic>
+    </p:spTree>
+    <p:extLst>
+      <p:ext uri="{BB962C8B-B14F-4D97-AF65-F5344CB8AC3E}">
+        <p14:creationId xmlns:p14="http://schemas.microsoft.com/office/powerpoint/2010/main" val="2473186269"/>
+      </p:ext>
+    </p:extLst>
+  </p:cSld>
+  <p:clrMapOvr>
+    <a:masterClrMapping/>
+  </p:clrMapOvr>
+</p:sld>
+</file>
+
+<file path=ppt/slides/slide2.xml><?xml version="1.0" encoding="utf-8"?>
+<p:sld xmlns:a="http://schemas.openxmlformats.org/drawingml/2006/main" xmlns:r="http://schemas.openxmlformats.org/officeDocument/2006/relationships" xmlns:p="http://schemas.openxmlformats.org/presentationml/2006/main">
+  <p:cSld>
+    <p:spTree>
+      <p:nvGrpSpPr>
+        <p:cNvPr id="1" name=""/>
+        <p:cNvGrpSpPr/>
+        <p:nvPr/>
+      </p:nvGrpSpPr>
+      <p:grpSpPr>
+        <a:xfrm>
+          <a:off x="0" y="0"/>
+          <a:ext cx="0" cy="0"/>
+          <a:chOff x="0" y="0"/>
+          <a:chExt cx="0" cy="0"/>
+        </a:xfrm>
+      </p:grpSpPr>
+      <p:pic>
+        <p:nvPicPr>
+          <p:cNvPr id="3" name="Picture 2" descr="A diagram of a diagram&#10;&#10;AI-generated content may be incorrect.">
+            <a:extLst>
+              <a:ext uri="{FF2B5EF4-FFF2-40B4-BE49-F238E27FC236}">
+                <a16:creationId xmlns:a16="http://schemas.microsoft.com/office/drawing/2014/main" id="{5A7D5239-49B3-F030-7E03-7902802C97AF}"/>
+              </a:ext>
+            </a:extLst>
+          </p:cNvPr>
+          <p:cNvPicPr>
+            <a:picLocks noChangeAspect="1"/>
+          </p:cNvPicPr>
+          <p:nvPr/>
+        </p:nvPicPr>
+        <p:blipFill>
+          <a:blip r:embed="rId2"/>
+          <a:stretch>
+            <a:fillRect/>
+          </a:stretch>
+        </p:blipFill>
+        <p:spPr>
+          <a:xfrm>
+            <a:off x="577849" y="720687"/>
+            <a:ext cx="11036301" cy="5416625"/>
+          </a:xfrm>
+          <a:prstGeom prst="rect">
+            <a:avLst/>
+          </a:prstGeom>
+        </p:spPr>
+      </p:pic>
+      <p:sp>
+        <p:nvSpPr>
+          <p:cNvPr id="4" name="Content Placeholder 2">
+            <a:extLst>
+              <a:ext uri="{FF2B5EF4-FFF2-40B4-BE49-F238E27FC236}">
+                <a16:creationId xmlns:a16="http://schemas.microsoft.com/office/drawing/2014/main" id="{8A64EEFD-FFE1-2A19-E81D-B026E60F3C7A}"/>
               </a:ext>
             </a:extLst>
           </p:cNvPr>
@@ -4013,8 +4175,8 @@
         </p:nvSpPr>
         <p:spPr>
           <a:xfrm>
-            <a:off x="340658" y="1825625"/>
-            <a:ext cx="8060392" cy="4351338"/>
+            <a:off x="2956858" y="6178624"/>
+            <a:ext cx="2796242" cy="568288"/>
           </a:xfrm>
           <a:prstGeom prst="rect">
             <a:avLst/>
@@ -4187,187 +4349,37 @@
             </a:lvl9pPr>
           </a:lstStyle>
           <a:p>
-            <a:r>
-              <a:rPr lang="nl-NL" dirty="0" err="1">
+            <a:pPr marL="0" indent="0" algn="ctr">
+              <a:buNone/>
+            </a:pPr>
+            <a:r>
+              <a:rPr lang="en-NL" dirty="0">
                 <a:latin typeface="Helvetica Neue" panose="02000503000000020004" pitchFamily="2" charset="0"/>
                 <a:ea typeface="Helvetica Neue" panose="02000503000000020004" pitchFamily="2" charset="0"/>
                 <a:cs typeface="Helvetica Neue" panose="02000503000000020004" pitchFamily="2" charset="0"/>
               </a:rPr>
-              <a:t>Add</a:t>
-            </a:r>
-            <a:r>
-              <a:rPr lang="nl-NL" dirty="0">
-                <a:latin typeface="Helvetica Neue" panose="02000503000000020004" pitchFamily="2" charset="0"/>
-                <a:ea typeface="Helvetica Neue" panose="02000503000000020004" pitchFamily="2" charset="0"/>
-                <a:cs typeface="Helvetica Neue" panose="02000503000000020004" pitchFamily="2" charset="0"/>
-              </a:rPr>
-              <a:t> folder </a:t>
-            </a:r>
-            <a:r>
-              <a:rPr lang="nl-NL" dirty="0" err="1">
-                <a:latin typeface="Helvetica Neue" panose="02000503000000020004" pitchFamily="2" charset="0"/>
-                <a:ea typeface="Helvetica Neue" panose="02000503000000020004" pitchFamily="2" charset="0"/>
-                <a:cs typeface="Helvetica Neue" panose="02000503000000020004" pitchFamily="2" charset="0"/>
-              </a:rPr>
-              <a:t>structure</a:t>
-            </a:r>
-            <a:r>
-              <a:rPr lang="nl-NL" dirty="0">
-                <a:latin typeface="Helvetica Neue" panose="02000503000000020004" pitchFamily="2" charset="0"/>
-                <a:ea typeface="Helvetica Neue" panose="02000503000000020004" pitchFamily="2" charset="0"/>
-                <a:cs typeface="Helvetica Neue" panose="02000503000000020004" pitchFamily="2" charset="0"/>
-              </a:rPr>
-              <a:t> </a:t>
-            </a:r>
-            <a:r>
-              <a:rPr lang="nl-NL" dirty="0" err="1">
-                <a:latin typeface="Helvetica Neue" panose="02000503000000020004" pitchFamily="2" charset="0"/>
-                <a:ea typeface="Helvetica Neue" panose="02000503000000020004" pitchFamily="2" charset="0"/>
-                <a:cs typeface="Helvetica Neue" panose="02000503000000020004" pitchFamily="2" charset="0"/>
-              </a:rPr>
-              <a:t>with</a:t>
-            </a:r>
-            <a:r>
-              <a:rPr lang="nl-NL" dirty="0">
-                <a:latin typeface="Helvetica Neue" panose="02000503000000020004" pitchFamily="2" charset="0"/>
-                <a:ea typeface="Helvetica Neue" panose="02000503000000020004" pitchFamily="2" charset="0"/>
-                <a:cs typeface="Helvetica Neue" panose="02000503000000020004" pitchFamily="2" charset="0"/>
-              </a:rPr>
-              <a:t> </a:t>
-            </a:r>
-            <a:r>
-              <a:rPr lang="nl-NL" dirty="0" err="1">
-                <a:latin typeface="Helvetica Neue" panose="02000503000000020004" pitchFamily="2" charset="0"/>
-                <a:ea typeface="Helvetica Neue" panose="02000503000000020004" pitchFamily="2" charset="0"/>
-                <a:cs typeface="Helvetica Neue" panose="02000503000000020004" pitchFamily="2" charset="0"/>
-              </a:rPr>
-              <a:t>count</a:t>
-            </a:r>
-            <a:r>
-              <a:rPr lang="nl-NL" dirty="0">
-                <a:latin typeface="Helvetica Neue" panose="02000503000000020004" pitchFamily="2" charset="0"/>
-                <a:ea typeface="Helvetica Neue" panose="02000503000000020004" pitchFamily="2" charset="0"/>
-                <a:cs typeface="Helvetica Neue" panose="02000503000000020004" pitchFamily="2" charset="0"/>
-              </a:rPr>
-              <a:t> </a:t>
-            </a:r>
-            <a:r>
-              <a:rPr lang="nl-NL" dirty="0" err="1">
-                <a:latin typeface="Helvetica Neue" panose="02000503000000020004" pitchFamily="2" charset="0"/>
-                <a:ea typeface="Helvetica Neue" panose="02000503000000020004" pitchFamily="2" charset="0"/>
-                <a:cs typeface="Helvetica Neue" panose="02000503000000020004" pitchFamily="2" charset="0"/>
-              </a:rPr>
-              <a:t>table</a:t>
-            </a:r>
-            <a:r>
-              <a:rPr lang="nl-NL" dirty="0">
-                <a:latin typeface="Helvetica Neue" panose="02000503000000020004" pitchFamily="2" charset="0"/>
-                <a:ea typeface="Helvetica Neue" panose="02000503000000020004" pitchFamily="2" charset="0"/>
-                <a:cs typeface="Helvetica Neue" panose="02000503000000020004" pitchFamily="2" charset="0"/>
-              </a:rPr>
-              <a:t> name </a:t>
-            </a:r>
-            <a:r>
-              <a:rPr lang="nl-NL" dirty="0" err="1">
-                <a:latin typeface="Helvetica Neue" panose="02000503000000020004" pitchFamily="2" charset="0"/>
-                <a:ea typeface="Helvetica Neue" panose="02000503000000020004" pitchFamily="2" charset="0"/>
-                <a:cs typeface="Helvetica Neue" panose="02000503000000020004" pitchFamily="2" charset="0"/>
-              </a:rPr>
-              <a:t>here</a:t>
-            </a:r>
-            <a:r>
-              <a:rPr lang="nl-NL" dirty="0">
-                <a:latin typeface="Helvetica Neue" panose="02000503000000020004" pitchFamily="2" charset="0"/>
-                <a:ea typeface="Helvetica Neue" panose="02000503000000020004" pitchFamily="2" charset="0"/>
-                <a:cs typeface="Helvetica Neue" panose="02000503000000020004" pitchFamily="2" charset="0"/>
-              </a:rPr>
-              <a:t>.</a:t>
-            </a:r>
-            <a:endParaRPr lang="en-NL" dirty="0">
-              <a:latin typeface="Helvetica Neue" panose="02000503000000020004" pitchFamily="2" charset="0"/>
-              <a:ea typeface="Helvetica Neue" panose="02000503000000020004" pitchFamily="2" charset="0"/>
-              <a:cs typeface="Helvetica Neue" panose="02000503000000020004" pitchFamily="2" charset="0"/>
-            </a:endParaRPr>
-          </a:p>
-        </p:txBody>
-      </p:sp>
-    </p:spTree>
-    <p:extLst>
-      <p:ext uri="{BB962C8B-B14F-4D97-AF65-F5344CB8AC3E}">
-        <p14:creationId xmlns:p14="http://schemas.microsoft.com/office/powerpoint/2010/main" val="2473186269"/>
-      </p:ext>
-    </p:extLst>
-  </p:cSld>
-  <p:clrMapOvr>
-    <a:masterClrMapping/>
-  </p:clrMapOvr>
-</p:sld>
-</file>
-
-<file path=ppt/slides/slide2.xml><?xml version="1.0" encoding="utf-8"?>
-<p:sld xmlns:a="http://schemas.openxmlformats.org/drawingml/2006/main" xmlns:r="http://schemas.openxmlformats.org/officeDocument/2006/relationships" xmlns:p="http://schemas.openxmlformats.org/presentationml/2006/main">
-  <p:cSld>
-    <p:spTree>
-      <p:nvGrpSpPr>
-        <p:cNvPr id="1" name=""/>
-        <p:cNvGrpSpPr/>
-        <p:nvPr/>
-      </p:nvGrpSpPr>
-      <p:grpSpPr>
-        <a:xfrm>
-          <a:off x="0" y="0"/>
-          <a:ext cx="0" cy="0"/>
-          <a:chOff x="0" y="0"/>
-          <a:chExt cx="0" cy="0"/>
-        </a:xfrm>
-      </p:grpSpPr>
-      <p:pic>
-        <p:nvPicPr>
-          <p:cNvPr id="3" name="Picture 2" descr="A diagram of a diagram&#10;&#10;AI-generated content may be incorrect.">
-            <a:extLst>
-              <a:ext uri="{FF2B5EF4-FFF2-40B4-BE49-F238E27FC236}">
-                <a16:creationId xmlns:a16="http://schemas.microsoft.com/office/drawing/2014/main" id="{5A7D5239-49B3-F030-7E03-7902802C97AF}"/>
-              </a:ext>
-            </a:extLst>
-          </p:cNvPr>
-          <p:cNvPicPr>
-            <a:picLocks noChangeAspect="1"/>
-          </p:cNvPicPr>
+              <a:t>Day 1</a:t>
+            </a:r>
+          </a:p>
+        </p:txBody>
+      </p:sp>
+      <p:sp>
+        <p:nvSpPr>
+          <p:cNvPr id="5" name="Content Placeholder 2">
+            <a:extLst>
+              <a:ext uri="{FF2B5EF4-FFF2-40B4-BE49-F238E27FC236}">
+                <a16:creationId xmlns:a16="http://schemas.microsoft.com/office/drawing/2014/main" id="{FC05A2C4-6883-519E-25DA-E8FAD701ED0E}"/>
+              </a:ext>
+            </a:extLst>
+          </p:cNvPr>
+          <p:cNvSpPr txBox="1">
+            <a:spLocks/>
+          </p:cNvSpPr>
           <p:nvPr/>
-        </p:nvPicPr>
-        <p:blipFill>
-          <a:blip r:embed="rId2"/>
-          <a:stretch>
-            <a:fillRect/>
-          </a:stretch>
-        </p:blipFill>
+        </p:nvSpPr>
         <p:spPr>
           <a:xfrm>
-            <a:off x="577849" y="720687"/>
-            <a:ext cx="11036301" cy="5416625"/>
-          </a:xfrm>
-          <a:prstGeom prst="rect">
-            <a:avLst/>
-          </a:prstGeom>
-        </p:spPr>
-      </p:pic>
-      <p:sp>
-        <p:nvSpPr>
-          <p:cNvPr id="4" name="Content Placeholder 2">
-            <a:extLst>
-              <a:ext uri="{FF2B5EF4-FFF2-40B4-BE49-F238E27FC236}">
-                <a16:creationId xmlns:a16="http://schemas.microsoft.com/office/drawing/2014/main" id="{8A64EEFD-FFE1-2A19-E81D-B026E60F3C7A}"/>
-              </a:ext>
-            </a:extLst>
-          </p:cNvPr>
-          <p:cNvSpPr txBox="1">
-            <a:spLocks/>
-          </p:cNvSpPr>
-          <p:nvPr/>
-        </p:nvSpPr>
-        <p:spPr>
-          <a:xfrm>
-            <a:off x="2956858" y="6178624"/>
+            <a:off x="8671858" y="6178624"/>
             <a:ext cx="2796242" cy="568288"/>
           </a:xfrm>
           <a:prstGeom prst="rect">
@@ -4545,22 +4557,396 @@
               <a:buNone/>
             </a:pPr>
             <a:r>
-              <a:rPr lang="en-NL" dirty="0">
+              <a:rPr lang="en-NL" b="1" dirty="0">
                 <a:latin typeface="Helvetica Neue" panose="02000503000000020004" pitchFamily="2" charset="0"/>
                 <a:ea typeface="Helvetica Neue" panose="02000503000000020004" pitchFamily="2" charset="0"/>
                 <a:cs typeface="Helvetica Neue" panose="02000503000000020004" pitchFamily="2" charset="0"/>
               </a:rPr>
-              <a:t>Day 1</a:t>
-            </a:r>
-          </a:p>
-        </p:txBody>
-      </p:sp>
-      <p:sp>
-        <p:nvSpPr>
-          <p:cNvPr id="5" name="Content Placeholder 2">
-            <a:extLst>
-              <a:ext uri="{FF2B5EF4-FFF2-40B4-BE49-F238E27FC236}">
-                <a16:creationId xmlns:a16="http://schemas.microsoft.com/office/drawing/2014/main" id="{FC05A2C4-6883-519E-25DA-E8FAD701ED0E}"/>
+              <a:t>Day 2</a:t>
+            </a:r>
+          </a:p>
+        </p:txBody>
+      </p:sp>
+      <p:sp>
+        <p:nvSpPr>
+          <p:cNvPr id="2" name="Rectangle 1">
+            <a:extLst>
+              <a:ext uri="{FF2B5EF4-FFF2-40B4-BE49-F238E27FC236}">
+                <a16:creationId xmlns:a16="http://schemas.microsoft.com/office/drawing/2014/main" id="{76890C07-9A42-78CC-9424-531452A338DB}"/>
+              </a:ext>
+            </a:extLst>
+          </p:cNvPr>
+          <p:cNvSpPr/>
+          <p:nvPr/>
+        </p:nvSpPr>
+        <p:spPr>
+          <a:xfrm>
+            <a:off x="342900" y="480060"/>
+            <a:ext cx="7806690" cy="6137910"/>
+          </a:xfrm>
+          <a:prstGeom prst="rect">
+            <a:avLst/>
+          </a:prstGeom>
+          <a:solidFill>
+            <a:srgbClr val="FFFFFF">
+              <a:alpha val="80000"/>
+            </a:srgbClr>
+          </a:solidFill>
+          <a:ln>
+            <a:noFill/>
+          </a:ln>
+        </p:spPr>
+        <p:style>
+          <a:lnRef idx="2">
+            <a:schemeClr val="accent1">
+              <a:shade val="15000"/>
+            </a:schemeClr>
+          </a:lnRef>
+          <a:fillRef idx="1">
+            <a:schemeClr val="accent1"/>
+          </a:fillRef>
+          <a:effectRef idx="0">
+            <a:schemeClr val="accent1"/>
+          </a:effectRef>
+          <a:fontRef idx="minor">
+            <a:schemeClr val="lt1"/>
+          </a:fontRef>
+        </p:style>
+        <p:txBody>
+          <a:bodyPr rtlCol="0" anchor="ctr"/>
+          <a:lstStyle/>
+          <a:p>
+            <a:pPr algn="ctr"/>
+            <a:endParaRPr lang="en-NL"/>
+          </a:p>
+        </p:txBody>
+      </p:sp>
+    </p:spTree>
+    <p:extLst>
+      <p:ext uri="{BB962C8B-B14F-4D97-AF65-F5344CB8AC3E}">
+        <p14:creationId xmlns:p14="http://schemas.microsoft.com/office/powerpoint/2010/main" val="1101263866"/>
+      </p:ext>
+    </p:extLst>
+  </p:cSld>
+  <p:clrMapOvr>
+    <a:masterClrMapping/>
+  </p:clrMapOvr>
+</p:sld>
+</file>
+
+<file path=ppt/slides/slide3.xml><?xml version="1.0" encoding="utf-8"?>
+<p:sld xmlns:a="http://schemas.openxmlformats.org/drawingml/2006/main" xmlns:r="http://schemas.openxmlformats.org/officeDocument/2006/relationships" xmlns:p="http://schemas.openxmlformats.org/presentationml/2006/main">
+  <p:cSld>
+    <p:spTree>
+      <p:nvGrpSpPr>
+        <p:cNvPr id="1" name=""/>
+        <p:cNvGrpSpPr/>
+        <p:nvPr/>
+      </p:nvGrpSpPr>
+      <p:grpSpPr>
+        <a:xfrm>
+          <a:off x="0" y="0"/>
+          <a:ext cx="0" cy="0"/>
+          <a:chOff x="0" y="0"/>
+          <a:chExt cx="0" cy="0"/>
+        </a:xfrm>
+      </p:grpSpPr>
+      <p:pic>
+        <p:nvPicPr>
+          <p:cNvPr id="3" name="Picture 2">
+            <a:extLst>
+              <a:ext uri="{FF2B5EF4-FFF2-40B4-BE49-F238E27FC236}">
+                <a16:creationId xmlns:a16="http://schemas.microsoft.com/office/drawing/2014/main" id="{72FBB312-173D-E4DA-2F89-308E69EEE75F}"/>
+              </a:ext>
+            </a:extLst>
+          </p:cNvPr>
+          <p:cNvPicPr>
+            <a:picLocks noChangeAspect="1"/>
+          </p:cNvPicPr>
+          <p:nvPr/>
+        </p:nvPicPr>
+        <p:blipFill>
+          <a:blip r:embed="rId2"/>
+          <a:stretch>
+            <a:fillRect/>
+          </a:stretch>
+        </p:blipFill>
+        <p:spPr>
+          <a:xfrm>
+            <a:off x="0" y="447139"/>
+            <a:ext cx="12151003" cy="5963722"/>
+          </a:xfrm>
+          <a:prstGeom prst="rect">
+            <a:avLst/>
+          </a:prstGeom>
+        </p:spPr>
+      </p:pic>
+      <p:sp>
+        <p:nvSpPr>
+          <p:cNvPr id="4" name="Rectangle 3">
+            <a:extLst>
+              <a:ext uri="{FF2B5EF4-FFF2-40B4-BE49-F238E27FC236}">
+                <a16:creationId xmlns:a16="http://schemas.microsoft.com/office/drawing/2014/main" id="{D254A667-93E4-2838-70AC-8A2D42B496C7}"/>
+              </a:ext>
+            </a:extLst>
+          </p:cNvPr>
+          <p:cNvSpPr/>
+          <p:nvPr/>
+        </p:nvSpPr>
+        <p:spPr>
+          <a:xfrm>
+            <a:off x="4229101" y="1199213"/>
+            <a:ext cx="3726180" cy="1132507"/>
+          </a:xfrm>
+          <a:prstGeom prst="rect">
+            <a:avLst/>
+          </a:prstGeom>
+          <a:solidFill>
+            <a:srgbClr val="FFDFC2"/>
+          </a:solidFill>
+          <a:ln>
+            <a:noFill/>
+          </a:ln>
+        </p:spPr>
+        <p:style>
+          <a:lnRef idx="2">
+            <a:schemeClr val="accent1">
+              <a:shade val="15000"/>
+            </a:schemeClr>
+          </a:lnRef>
+          <a:fillRef idx="1">
+            <a:schemeClr val="accent1"/>
+          </a:fillRef>
+          <a:effectRef idx="0">
+            <a:schemeClr val="accent1"/>
+          </a:effectRef>
+          <a:fontRef idx="minor">
+            <a:schemeClr val="lt1"/>
+          </a:fontRef>
+        </p:style>
+        <p:txBody>
+          <a:bodyPr rtlCol="0" anchor="ctr"/>
+          <a:lstStyle/>
+          <a:p>
+            <a:pPr algn="ctr"/>
+            <a:endParaRPr lang="en-NL"/>
+          </a:p>
+        </p:txBody>
+      </p:sp>
+      <p:sp>
+        <p:nvSpPr>
+          <p:cNvPr id="5" name="Rectangle 4">
+            <a:extLst>
+              <a:ext uri="{FF2B5EF4-FFF2-40B4-BE49-F238E27FC236}">
+                <a16:creationId xmlns:a16="http://schemas.microsoft.com/office/drawing/2014/main" id="{00AEA871-4D2B-B284-FC20-2FC6634C2E62}"/>
+              </a:ext>
+            </a:extLst>
+          </p:cNvPr>
+          <p:cNvSpPr/>
+          <p:nvPr/>
+        </p:nvSpPr>
+        <p:spPr>
+          <a:xfrm>
+            <a:off x="7776210" y="1100153"/>
+            <a:ext cx="4179569" cy="4089067"/>
+          </a:xfrm>
+          <a:prstGeom prst="rect">
+            <a:avLst/>
+          </a:prstGeom>
+          <a:solidFill>
+            <a:srgbClr val="FFDFC2"/>
+          </a:solidFill>
+          <a:ln>
+            <a:noFill/>
+          </a:ln>
+        </p:spPr>
+        <p:style>
+          <a:lnRef idx="2">
+            <a:schemeClr val="accent1">
+              <a:shade val="15000"/>
+            </a:schemeClr>
+          </a:lnRef>
+          <a:fillRef idx="1">
+            <a:schemeClr val="accent1"/>
+          </a:fillRef>
+          <a:effectRef idx="0">
+            <a:schemeClr val="accent1"/>
+          </a:effectRef>
+          <a:fontRef idx="minor">
+            <a:schemeClr val="lt1"/>
+          </a:fontRef>
+        </p:style>
+        <p:txBody>
+          <a:bodyPr rtlCol="0" anchor="ctr"/>
+          <a:lstStyle/>
+          <a:p>
+            <a:pPr algn="ctr"/>
+            <a:endParaRPr lang="en-NL"/>
+          </a:p>
+        </p:txBody>
+      </p:sp>
+      <p:sp>
+        <p:nvSpPr>
+          <p:cNvPr id="6" name="Rectangle 5">
+            <a:extLst>
+              <a:ext uri="{FF2B5EF4-FFF2-40B4-BE49-F238E27FC236}">
+                <a16:creationId xmlns:a16="http://schemas.microsoft.com/office/drawing/2014/main" id="{5E686508-A30F-3573-6ECC-FA2AD05DA1BF}"/>
+              </a:ext>
+            </a:extLst>
+          </p:cNvPr>
+          <p:cNvSpPr/>
+          <p:nvPr/>
+        </p:nvSpPr>
+        <p:spPr>
+          <a:xfrm>
+            <a:off x="1684021" y="2430780"/>
+            <a:ext cx="3505199" cy="2454860"/>
+          </a:xfrm>
+          <a:prstGeom prst="rect">
+            <a:avLst/>
+          </a:prstGeom>
+          <a:solidFill>
+            <a:srgbClr val="FFDFC2"/>
+          </a:solidFill>
+          <a:ln>
+            <a:noFill/>
+          </a:ln>
+        </p:spPr>
+        <p:style>
+          <a:lnRef idx="2">
+            <a:schemeClr val="accent1">
+              <a:shade val="15000"/>
+            </a:schemeClr>
+          </a:lnRef>
+          <a:fillRef idx="1">
+            <a:schemeClr val="accent1"/>
+          </a:fillRef>
+          <a:effectRef idx="0">
+            <a:schemeClr val="accent1"/>
+          </a:effectRef>
+          <a:fontRef idx="minor">
+            <a:schemeClr val="lt1"/>
+          </a:fontRef>
+        </p:style>
+        <p:txBody>
+          <a:bodyPr rtlCol="0" anchor="ctr"/>
+          <a:lstStyle/>
+          <a:p>
+            <a:pPr algn="ctr"/>
+            <a:endParaRPr lang="en-NL"/>
+          </a:p>
+        </p:txBody>
+      </p:sp>
+      <p:sp>
+        <p:nvSpPr>
+          <p:cNvPr id="7" name="Rectangle 6">
+            <a:extLst>
+              <a:ext uri="{FF2B5EF4-FFF2-40B4-BE49-F238E27FC236}">
+                <a16:creationId xmlns:a16="http://schemas.microsoft.com/office/drawing/2014/main" id="{D78CE0C5-FCBC-0CAC-12DF-B133162CA546}"/>
+              </a:ext>
+            </a:extLst>
+          </p:cNvPr>
+          <p:cNvSpPr/>
+          <p:nvPr/>
+        </p:nvSpPr>
+        <p:spPr>
+          <a:xfrm>
+            <a:off x="4339591" y="3784550"/>
+            <a:ext cx="3505199" cy="1272540"/>
+          </a:xfrm>
+          <a:prstGeom prst="rect">
+            <a:avLst/>
+          </a:prstGeom>
+          <a:solidFill>
+            <a:srgbClr val="FFDFC2"/>
+          </a:solidFill>
+          <a:ln>
+            <a:noFill/>
+          </a:ln>
+        </p:spPr>
+        <p:style>
+          <a:lnRef idx="2">
+            <a:schemeClr val="accent1">
+              <a:shade val="15000"/>
+            </a:schemeClr>
+          </a:lnRef>
+          <a:fillRef idx="1">
+            <a:schemeClr val="accent1"/>
+          </a:fillRef>
+          <a:effectRef idx="0">
+            <a:schemeClr val="accent1"/>
+          </a:effectRef>
+          <a:fontRef idx="minor">
+            <a:schemeClr val="lt1"/>
+          </a:fontRef>
+        </p:style>
+        <p:txBody>
+          <a:bodyPr rtlCol="0" anchor="ctr"/>
+          <a:lstStyle/>
+          <a:p>
+            <a:pPr algn="ctr"/>
+            <a:endParaRPr lang="en-NL"/>
+          </a:p>
+        </p:txBody>
+      </p:sp>
+      <p:sp>
+        <p:nvSpPr>
+          <p:cNvPr id="8" name="Rectangle 7">
+            <a:extLst>
+              <a:ext uri="{FF2B5EF4-FFF2-40B4-BE49-F238E27FC236}">
+                <a16:creationId xmlns:a16="http://schemas.microsoft.com/office/drawing/2014/main" id="{425DC1C5-6B92-CEE2-6E8F-1848F99440A9}"/>
+              </a:ext>
+            </a:extLst>
+          </p:cNvPr>
+          <p:cNvSpPr/>
+          <p:nvPr/>
+        </p:nvSpPr>
+        <p:spPr>
+          <a:xfrm>
+            <a:off x="2977516" y="4885640"/>
+            <a:ext cx="3505199" cy="1272540"/>
+          </a:xfrm>
+          <a:prstGeom prst="rect">
+            <a:avLst/>
+          </a:prstGeom>
+          <a:solidFill>
+            <a:srgbClr val="FFDFC2"/>
+          </a:solidFill>
+          <a:ln>
+            <a:noFill/>
+          </a:ln>
+        </p:spPr>
+        <p:style>
+          <a:lnRef idx="2">
+            <a:schemeClr val="accent1">
+              <a:shade val="15000"/>
+            </a:schemeClr>
+          </a:lnRef>
+          <a:fillRef idx="1">
+            <a:schemeClr val="accent1"/>
+          </a:fillRef>
+          <a:effectRef idx="0">
+            <a:schemeClr val="accent1"/>
+          </a:effectRef>
+          <a:fontRef idx="minor">
+            <a:schemeClr val="lt1"/>
+          </a:fontRef>
+        </p:style>
+        <p:txBody>
+          <a:bodyPr rtlCol="0" anchor="ctr"/>
+          <a:lstStyle/>
+          <a:p>
+            <a:pPr algn="ctr"/>
+            <a:endParaRPr lang="en-NL"/>
+          </a:p>
+        </p:txBody>
+      </p:sp>
+      <p:sp>
+        <p:nvSpPr>
+          <p:cNvPr id="9" name="Content Placeholder 2">
+            <a:extLst>
+              <a:ext uri="{FF2B5EF4-FFF2-40B4-BE49-F238E27FC236}">
+                <a16:creationId xmlns:a16="http://schemas.microsoft.com/office/drawing/2014/main" id="{75D581B3-1F96-4782-1E64-5F2B11E02FA0}"/>
               </a:ext>
             </a:extLst>
           </p:cNvPr>
@@ -4571,8 +4957,8 @@
         </p:nvSpPr>
         <p:spPr>
           <a:xfrm>
-            <a:off x="8671858" y="6178624"/>
-            <a:ext cx="2796242" cy="568288"/>
+            <a:off x="40997" y="0"/>
+            <a:ext cx="4072592" cy="568288"/>
           </a:xfrm>
           <a:prstGeom prst="rect">
             <a:avLst/>
@@ -4754,17 +5140,83 @@
                 <a:ea typeface="Helvetica Neue" panose="02000503000000020004" pitchFamily="2" charset="0"/>
                 <a:cs typeface="Helvetica Neue" panose="02000503000000020004" pitchFamily="2" charset="0"/>
               </a:rPr>
-              <a:t>Day 2</a:t>
-            </a:r>
-          </a:p>
-        </p:txBody>
-      </p:sp>
-      <p:sp>
-        <p:nvSpPr>
-          <p:cNvPr id="2" name="Rectangle 1">
-            <a:extLst>
-              <a:ext uri="{FF2B5EF4-FFF2-40B4-BE49-F238E27FC236}">
-                <a16:creationId xmlns:a16="http://schemas.microsoft.com/office/drawing/2014/main" id="{76890C07-9A42-78CC-9424-531452A338DB}"/>
+              <a:t>Day 2 in more detail…</a:t>
+            </a:r>
+          </a:p>
+        </p:txBody>
+      </p:sp>
+    </p:spTree>
+    <p:extLst>
+      <p:ext uri="{BB962C8B-B14F-4D97-AF65-F5344CB8AC3E}">
+        <p14:creationId xmlns:p14="http://schemas.microsoft.com/office/powerpoint/2010/main" val="1030031058"/>
+      </p:ext>
+    </p:extLst>
+  </p:cSld>
+  <p:clrMapOvr>
+    <a:masterClrMapping/>
+  </p:clrMapOvr>
+</p:sld>
+</file>
+
+<file path=ppt/slides/slide4.xml><?xml version="1.0" encoding="utf-8"?>
+<p:sld xmlns:a="http://schemas.openxmlformats.org/drawingml/2006/main" xmlns:r="http://schemas.openxmlformats.org/officeDocument/2006/relationships" xmlns:p="http://schemas.openxmlformats.org/presentationml/2006/main">
+  <p:cSld>
+    <p:spTree>
+      <p:nvGrpSpPr>
+        <p:cNvPr id="1" name="">
+          <a:extLst>
+            <a:ext uri="{FF2B5EF4-FFF2-40B4-BE49-F238E27FC236}">
+              <a16:creationId xmlns:a16="http://schemas.microsoft.com/office/drawing/2014/main" id="{8821D57B-2310-A175-4DDC-EFA6941ABBB8}"/>
+            </a:ext>
+          </a:extLst>
+        </p:cNvPr>
+        <p:cNvGrpSpPr/>
+        <p:nvPr/>
+      </p:nvGrpSpPr>
+      <p:grpSpPr>
+        <a:xfrm>
+          <a:off x="0" y="0"/>
+          <a:ext cx="0" cy="0"/>
+          <a:chOff x="0" y="0"/>
+          <a:chExt cx="0" cy="0"/>
+        </a:xfrm>
+      </p:grpSpPr>
+      <p:pic>
+        <p:nvPicPr>
+          <p:cNvPr id="3" name="Picture 2">
+            <a:extLst>
+              <a:ext uri="{FF2B5EF4-FFF2-40B4-BE49-F238E27FC236}">
+                <a16:creationId xmlns:a16="http://schemas.microsoft.com/office/drawing/2014/main" id="{BB4FD7F7-B914-63E3-DDA6-5A360172C0DF}"/>
+              </a:ext>
+            </a:extLst>
+          </p:cNvPr>
+          <p:cNvPicPr>
+            <a:picLocks noChangeAspect="1"/>
+          </p:cNvPicPr>
+          <p:nvPr/>
+        </p:nvPicPr>
+        <p:blipFill>
+          <a:blip r:embed="rId2"/>
+          <a:stretch>
+            <a:fillRect/>
+          </a:stretch>
+        </p:blipFill>
+        <p:spPr>
+          <a:xfrm>
+            <a:off x="0" y="447139"/>
+            <a:ext cx="12151003" cy="5963722"/>
+          </a:xfrm>
+          <a:prstGeom prst="rect">
+            <a:avLst/>
+          </a:prstGeom>
+        </p:spPr>
+      </p:pic>
+      <p:sp>
+        <p:nvSpPr>
+          <p:cNvPr id="5" name="Rectangle 4">
+            <a:extLst>
+              <a:ext uri="{FF2B5EF4-FFF2-40B4-BE49-F238E27FC236}">
+                <a16:creationId xmlns:a16="http://schemas.microsoft.com/office/drawing/2014/main" id="{A762E375-D701-D242-3723-C41923A77C1D}"/>
               </a:ext>
             </a:extLst>
           </p:cNvPr>
@@ -4773,16 +5225,14 @@
         </p:nvSpPr>
         <p:spPr>
           <a:xfrm>
-            <a:off x="342900" y="480060"/>
-            <a:ext cx="7806690" cy="6137910"/>
+            <a:off x="7955280" y="1100153"/>
+            <a:ext cx="4000499" cy="4089067"/>
           </a:xfrm>
           <a:prstGeom prst="rect">
             <a:avLst/>
           </a:prstGeom>
           <a:solidFill>
-            <a:srgbClr val="FFFFFF">
-              <a:alpha val="80000"/>
-            </a:srgbClr>
+            <a:srgbClr val="FFDFC2"/>
           </a:solidFill>
           <a:ln>
             <a:noFill/>
@@ -4813,72 +5263,116 @@
           </a:p>
         </p:txBody>
       </p:sp>
-    </p:spTree>
-    <p:extLst>
-      <p:ext uri="{BB962C8B-B14F-4D97-AF65-F5344CB8AC3E}">
-        <p14:creationId xmlns:p14="http://schemas.microsoft.com/office/powerpoint/2010/main" val="1101263866"/>
-      </p:ext>
-    </p:extLst>
-  </p:cSld>
-  <p:clrMapOvr>
-    <a:masterClrMapping/>
-  </p:clrMapOvr>
-</p:sld>
-</file>
-
-<file path=ppt/slides/slide3.xml><?xml version="1.0" encoding="utf-8"?>
-<p:sld xmlns:a="http://schemas.openxmlformats.org/drawingml/2006/main" xmlns:r="http://schemas.openxmlformats.org/officeDocument/2006/relationships" xmlns:p="http://schemas.openxmlformats.org/presentationml/2006/main">
-  <p:cSld>
-    <p:spTree>
-      <p:nvGrpSpPr>
-        <p:cNvPr id="1" name=""/>
-        <p:cNvGrpSpPr/>
-        <p:nvPr/>
-      </p:nvGrpSpPr>
-      <p:grpSpPr>
-        <a:xfrm>
-          <a:off x="0" y="0"/>
-          <a:ext cx="0" cy="0"/>
-          <a:chOff x="0" y="0"/>
-          <a:chExt cx="0" cy="0"/>
-        </a:xfrm>
-      </p:grpSpPr>
-      <p:pic>
-        <p:nvPicPr>
-          <p:cNvPr id="3" name="Picture 2">
-            <a:extLst>
-              <a:ext uri="{FF2B5EF4-FFF2-40B4-BE49-F238E27FC236}">
-                <a16:creationId xmlns:a16="http://schemas.microsoft.com/office/drawing/2014/main" id="{72FBB312-173D-E4DA-2F89-308E69EEE75F}"/>
-              </a:ext>
-            </a:extLst>
-          </p:cNvPr>
-          <p:cNvPicPr>
-            <a:picLocks noChangeAspect="1"/>
-          </p:cNvPicPr>
+      <p:sp>
+        <p:nvSpPr>
+          <p:cNvPr id="7" name="Rectangle 6">
+            <a:extLst>
+              <a:ext uri="{FF2B5EF4-FFF2-40B4-BE49-F238E27FC236}">
+                <a16:creationId xmlns:a16="http://schemas.microsoft.com/office/drawing/2014/main" id="{09D97844-DE3A-9F95-A790-9666693DC8FC}"/>
+              </a:ext>
+            </a:extLst>
+          </p:cNvPr>
+          <p:cNvSpPr/>
           <p:nvPr/>
-        </p:nvPicPr>
-        <p:blipFill>
-          <a:blip r:embed="rId2"/>
-          <a:stretch>
-            <a:fillRect/>
-          </a:stretch>
-        </p:blipFill>
+        </p:nvSpPr>
         <p:spPr>
           <a:xfrm>
-            <a:off x="0" y="447139"/>
-            <a:ext cx="12151003" cy="5963722"/>
+            <a:off x="4339591" y="3784550"/>
+            <a:ext cx="3505199" cy="1272540"/>
           </a:xfrm>
           <a:prstGeom prst="rect">
             <a:avLst/>
           </a:prstGeom>
+          <a:solidFill>
+            <a:srgbClr val="FFDFC2"/>
+          </a:solidFill>
+          <a:ln>
+            <a:noFill/>
+          </a:ln>
         </p:spPr>
-      </p:pic>
-      <p:sp>
-        <p:nvSpPr>
-          <p:cNvPr id="4" name="Rectangle 3">
-            <a:extLst>
-              <a:ext uri="{FF2B5EF4-FFF2-40B4-BE49-F238E27FC236}">
-                <a16:creationId xmlns:a16="http://schemas.microsoft.com/office/drawing/2014/main" id="{D254A667-93E4-2838-70AC-8A2D42B496C7}"/>
+        <p:style>
+          <a:lnRef idx="2">
+            <a:schemeClr val="accent1">
+              <a:shade val="15000"/>
+            </a:schemeClr>
+          </a:lnRef>
+          <a:fillRef idx="1">
+            <a:schemeClr val="accent1"/>
+          </a:fillRef>
+          <a:effectRef idx="0">
+            <a:schemeClr val="accent1"/>
+          </a:effectRef>
+          <a:fontRef idx="minor">
+            <a:schemeClr val="lt1"/>
+          </a:fontRef>
+        </p:style>
+        <p:txBody>
+          <a:bodyPr rtlCol="0" anchor="ctr"/>
+          <a:lstStyle/>
+          <a:p>
+            <a:pPr algn="ctr"/>
+            <a:endParaRPr lang="en-NL"/>
+          </a:p>
+        </p:txBody>
+      </p:sp>
+      <p:sp>
+        <p:nvSpPr>
+          <p:cNvPr id="8" name="Rectangle 7">
+            <a:extLst>
+              <a:ext uri="{FF2B5EF4-FFF2-40B4-BE49-F238E27FC236}">
+                <a16:creationId xmlns:a16="http://schemas.microsoft.com/office/drawing/2014/main" id="{97B4F196-CB14-BE00-CFE0-654E3364515D}"/>
+              </a:ext>
+            </a:extLst>
+          </p:cNvPr>
+          <p:cNvSpPr/>
+          <p:nvPr/>
+        </p:nvSpPr>
+        <p:spPr>
+          <a:xfrm>
+            <a:off x="2977516" y="4885640"/>
+            <a:ext cx="3505199" cy="1272540"/>
+          </a:xfrm>
+          <a:prstGeom prst="rect">
+            <a:avLst/>
+          </a:prstGeom>
+          <a:solidFill>
+            <a:srgbClr val="FFDFC2"/>
+          </a:solidFill>
+          <a:ln>
+            <a:noFill/>
+          </a:ln>
+        </p:spPr>
+        <p:style>
+          <a:lnRef idx="2">
+            <a:schemeClr val="accent1">
+              <a:shade val="15000"/>
+            </a:schemeClr>
+          </a:lnRef>
+          <a:fillRef idx="1">
+            <a:schemeClr val="accent1"/>
+          </a:fillRef>
+          <a:effectRef idx="0">
+            <a:schemeClr val="accent1"/>
+          </a:effectRef>
+          <a:fontRef idx="minor">
+            <a:schemeClr val="lt1"/>
+          </a:fontRef>
+        </p:style>
+        <p:txBody>
+          <a:bodyPr rtlCol="0" anchor="ctr"/>
+          <a:lstStyle/>
+          <a:p>
+            <a:pPr algn="ctr"/>
+            <a:endParaRPr lang="en-NL"/>
+          </a:p>
+        </p:txBody>
+      </p:sp>
+      <p:sp>
+        <p:nvSpPr>
+          <p:cNvPr id="2" name="Rectangle 1">
+            <a:extLst>
+              <a:ext uri="{FF2B5EF4-FFF2-40B4-BE49-F238E27FC236}">
+                <a16:creationId xmlns:a16="http://schemas.microsoft.com/office/drawing/2014/main" id="{A51D29ED-FE88-1F00-F83A-361AF52319F4}"/>
               </a:ext>
             </a:extLst>
           </p:cNvPr>
@@ -4925,232 +5419,101 @@
           </a:p>
         </p:txBody>
       </p:sp>
-      <p:sp>
-        <p:nvSpPr>
-          <p:cNvPr id="5" name="Rectangle 4">
-            <a:extLst>
-              <a:ext uri="{FF2B5EF4-FFF2-40B4-BE49-F238E27FC236}">
-                <a16:creationId xmlns:a16="http://schemas.microsoft.com/office/drawing/2014/main" id="{00AEA871-4D2B-B284-FC20-2FC6634C2E62}"/>
-              </a:ext>
-            </a:extLst>
-          </p:cNvPr>
-          <p:cNvSpPr/>
+    </p:spTree>
+    <p:extLst>
+      <p:ext uri="{BB962C8B-B14F-4D97-AF65-F5344CB8AC3E}">
+        <p14:creationId xmlns:p14="http://schemas.microsoft.com/office/powerpoint/2010/main" val="3597044244"/>
+      </p:ext>
+    </p:extLst>
+  </p:cSld>
+  <p:clrMapOvr>
+    <a:masterClrMapping/>
+  </p:clrMapOvr>
+</p:sld>
+</file>
+
+<file path=ppt/slides/slide5.xml><?xml version="1.0" encoding="utf-8"?>
+<p:sld xmlns:a="http://schemas.openxmlformats.org/drawingml/2006/main" xmlns:r="http://schemas.openxmlformats.org/officeDocument/2006/relationships" xmlns:p="http://schemas.openxmlformats.org/presentationml/2006/main">
+  <p:cSld>
+    <p:spTree>
+      <p:nvGrpSpPr>
+        <p:cNvPr id="1" name=""/>
+        <p:cNvGrpSpPr/>
+        <p:nvPr/>
+      </p:nvGrpSpPr>
+      <p:grpSpPr>
+        <a:xfrm>
+          <a:off x="0" y="0"/>
+          <a:ext cx="0" cy="0"/>
+          <a:chOff x="0" y="0"/>
+          <a:chExt cx="0" cy="0"/>
+        </a:xfrm>
+      </p:grpSpPr>
+      <p:pic>
+        <p:nvPicPr>
+          <p:cNvPr id="2050" name="Picture 2">
+            <a:extLst>
+              <a:ext uri="{FF2B5EF4-FFF2-40B4-BE49-F238E27FC236}">
+                <a16:creationId xmlns:a16="http://schemas.microsoft.com/office/drawing/2014/main" id="{574F2DDA-7547-B349-3A3D-99B14E877774}"/>
+              </a:ext>
+            </a:extLst>
+          </p:cNvPr>
+          <p:cNvPicPr>
+            <a:picLocks noChangeAspect="1" noChangeArrowheads="1"/>
+          </p:cNvPicPr>
           <p:nvPr/>
-        </p:nvSpPr>
-        <p:spPr>
+        </p:nvPicPr>
+        <p:blipFill>
+          <a:blip r:embed="rId2">
+            <a:extLst>
+              <a:ext uri="{28A0092B-C50C-407E-A947-70E740481C1C}">
+                <a14:useLocalDpi xmlns:a14="http://schemas.microsoft.com/office/drawing/2010/main" val="0"/>
+              </a:ext>
+            </a:extLst>
+          </a:blip>
+          <a:srcRect/>
+          <a:stretch>
+            <a:fillRect/>
+          </a:stretch>
+        </p:blipFill>
+        <p:spPr bwMode="auto">
           <a:xfrm>
-            <a:off x="7776210" y="1100153"/>
-            <a:ext cx="4179569" cy="4089067"/>
+            <a:off x="274320" y="1074420"/>
+            <a:ext cx="11132820" cy="5566410"/>
           </a:xfrm>
           <a:prstGeom prst="rect">
             <a:avLst/>
           </a:prstGeom>
-          <a:solidFill>
-            <a:srgbClr val="FFDFC2"/>
-          </a:solidFill>
-          <a:ln>
-            <a:noFill/>
-          </a:ln>
+          <a:noFill/>
+          <a:extLst>
+            <a:ext uri="{909E8E84-426E-40DD-AFC4-6F175D3DCCD1}">
+              <a14:hiddenFill xmlns:a14="http://schemas.microsoft.com/office/drawing/2010/main">
+                <a:solidFill>
+                  <a:srgbClr val="FFFFFF"/>
+                </a:solidFill>
+              </a14:hiddenFill>
+            </a:ext>
+          </a:extLst>
         </p:spPr>
-        <p:style>
-          <a:lnRef idx="2">
-            <a:schemeClr val="accent1">
-              <a:shade val="15000"/>
-            </a:schemeClr>
-          </a:lnRef>
-          <a:fillRef idx="1">
-            <a:schemeClr val="accent1"/>
-          </a:fillRef>
-          <a:effectRef idx="0">
-            <a:schemeClr val="accent1"/>
-          </a:effectRef>
-          <a:fontRef idx="minor">
-            <a:schemeClr val="lt1"/>
-          </a:fontRef>
-        </p:style>
-        <p:txBody>
-          <a:bodyPr rtlCol="0" anchor="ctr"/>
-          <a:lstStyle/>
-          <a:p>
-            <a:pPr algn="ctr"/>
-            <a:endParaRPr lang="en-NL"/>
-          </a:p>
-        </p:txBody>
-      </p:sp>
-      <p:sp>
-        <p:nvSpPr>
-          <p:cNvPr id="6" name="Rectangle 5">
-            <a:extLst>
-              <a:ext uri="{FF2B5EF4-FFF2-40B4-BE49-F238E27FC236}">
-                <a16:creationId xmlns:a16="http://schemas.microsoft.com/office/drawing/2014/main" id="{5E686508-A30F-3573-6ECC-FA2AD05DA1BF}"/>
-              </a:ext>
-            </a:extLst>
-          </p:cNvPr>
-          <p:cNvSpPr/>
+      </p:pic>
+      <p:sp>
+        <p:nvSpPr>
+          <p:cNvPr id="2" name="Content Placeholder 2">
+            <a:extLst>
+              <a:ext uri="{FF2B5EF4-FFF2-40B4-BE49-F238E27FC236}">
+                <a16:creationId xmlns:a16="http://schemas.microsoft.com/office/drawing/2014/main" id="{D47806BB-518C-F60B-C704-AB013DCEFF62}"/>
+              </a:ext>
+            </a:extLst>
+          </p:cNvPr>
+          <p:cNvSpPr txBox="1">
+            <a:spLocks/>
+          </p:cNvSpPr>
           <p:nvPr/>
         </p:nvSpPr>
         <p:spPr>
           <a:xfrm>
-            <a:off x="1684021" y="2430780"/>
-            <a:ext cx="3505199" cy="2454860"/>
-          </a:xfrm>
-          <a:prstGeom prst="rect">
-            <a:avLst/>
-          </a:prstGeom>
-          <a:solidFill>
-            <a:srgbClr val="FFDFC2"/>
-          </a:solidFill>
-          <a:ln>
-            <a:noFill/>
-          </a:ln>
-        </p:spPr>
-        <p:style>
-          <a:lnRef idx="2">
-            <a:schemeClr val="accent1">
-              <a:shade val="15000"/>
-            </a:schemeClr>
-          </a:lnRef>
-          <a:fillRef idx="1">
-            <a:schemeClr val="accent1"/>
-          </a:fillRef>
-          <a:effectRef idx="0">
-            <a:schemeClr val="accent1"/>
-          </a:effectRef>
-          <a:fontRef idx="minor">
-            <a:schemeClr val="lt1"/>
-          </a:fontRef>
-        </p:style>
-        <p:txBody>
-          <a:bodyPr rtlCol="0" anchor="ctr"/>
-          <a:lstStyle/>
-          <a:p>
-            <a:pPr algn="ctr"/>
-            <a:endParaRPr lang="en-NL"/>
-          </a:p>
-        </p:txBody>
-      </p:sp>
-      <p:sp>
-        <p:nvSpPr>
-          <p:cNvPr id="7" name="Rectangle 6">
-            <a:extLst>
-              <a:ext uri="{FF2B5EF4-FFF2-40B4-BE49-F238E27FC236}">
-                <a16:creationId xmlns:a16="http://schemas.microsoft.com/office/drawing/2014/main" id="{D78CE0C5-FCBC-0CAC-12DF-B133162CA546}"/>
-              </a:ext>
-            </a:extLst>
-          </p:cNvPr>
-          <p:cNvSpPr/>
-          <p:nvPr/>
-        </p:nvSpPr>
-        <p:spPr>
-          <a:xfrm>
-            <a:off x="4339591" y="3784550"/>
-            <a:ext cx="3505199" cy="1272540"/>
-          </a:xfrm>
-          <a:prstGeom prst="rect">
-            <a:avLst/>
-          </a:prstGeom>
-          <a:solidFill>
-            <a:srgbClr val="FFDFC2"/>
-          </a:solidFill>
-          <a:ln>
-            <a:noFill/>
-          </a:ln>
-        </p:spPr>
-        <p:style>
-          <a:lnRef idx="2">
-            <a:schemeClr val="accent1">
-              <a:shade val="15000"/>
-            </a:schemeClr>
-          </a:lnRef>
-          <a:fillRef idx="1">
-            <a:schemeClr val="accent1"/>
-          </a:fillRef>
-          <a:effectRef idx="0">
-            <a:schemeClr val="accent1"/>
-          </a:effectRef>
-          <a:fontRef idx="minor">
-            <a:schemeClr val="lt1"/>
-          </a:fontRef>
-        </p:style>
-        <p:txBody>
-          <a:bodyPr rtlCol="0" anchor="ctr"/>
-          <a:lstStyle/>
-          <a:p>
-            <a:pPr algn="ctr"/>
-            <a:endParaRPr lang="en-NL"/>
-          </a:p>
-        </p:txBody>
-      </p:sp>
-      <p:sp>
-        <p:nvSpPr>
-          <p:cNvPr id="8" name="Rectangle 7">
-            <a:extLst>
-              <a:ext uri="{FF2B5EF4-FFF2-40B4-BE49-F238E27FC236}">
-                <a16:creationId xmlns:a16="http://schemas.microsoft.com/office/drawing/2014/main" id="{425DC1C5-6B92-CEE2-6E8F-1848F99440A9}"/>
-              </a:ext>
-            </a:extLst>
-          </p:cNvPr>
-          <p:cNvSpPr/>
-          <p:nvPr/>
-        </p:nvSpPr>
-        <p:spPr>
-          <a:xfrm>
-            <a:off x="2977516" y="4885640"/>
-            <a:ext cx="3505199" cy="1272540"/>
-          </a:xfrm>
-          <a:prstGeom prst="rect">
-            <a:avLst/>
-          </a:prstGeom>
-          <a:solidFill>
-            <a:srgbClr val="FFDFC2"/>
-          </a:solidFill>
-          <a:ln>
-            <a:noFill/>
-          </a:ln>
-        </p:spPr>
-        <p:style>
-          <a:lnRef idx="2">
-            <a:schemeClr val="accent1">
-              <a:shade val="15000"/>
-            </a:schemeClr>
-          </a:lnRef>
-          <a:fillRef idx="1">
-            <a:schemeClr val="accent1"/>
-          </a:fillRef>
-          <a:effectRef idx="0">
-            <a:schemeClr val="accent1"/>
-          </a:effectRef>
-          <a:fontRef idx="minor">
-            <a:schemeClr val="lt1"/>
-          </a:fontRef>
-        </p:style>
-        <p:txBody>
-          <a:bodyPr rtlCol="0" anchor="ctr"/>
-          <a:lstStyle/>
-          <a:p>
-            <a:pPr algn="ctr"/>
-            <a:endParaRPr lang="en-NL"/>
-          </a:p>
-        </p:txBody>
-      </p:sp>
-      <p:sp>
-        <p:nvSpPr>
-          <p:cNvPr id="9" name="Content Placeholder 2">
-            <a:extLst>
-              <a:ext uri="{FF2B5EF4-FFF2-40B4-BE49-F238E27FC236}">
-                <a16:creationId xmlns:a16="http://schemas.microsoft.com/office/drawing/2014/main" id="{75D581B3-1F96-4782-1E64-5F2B11E02FA0}"/>
-              </a:ext>
-            </a:extLst>
-          </p:cNvPr>
-          <p:cNvSpPr txBox="1">
-            <a:spLocks/>
-          </p:cNvSpPr>
-          <p:nvPr/>
-        </p:nvSpPr>
-        <p:spPr>
-          <a:xfrm>
-            <a:off x="40997" y="0"/>
-            <a:ext cx="4072592" cy="568288"/>
+            <a:off x="49530" y="217170"/>
+            <a:ext cx="10461962" cy="568288"/>
           </a:xfrm>
           <a:prstGeom prst="rect">
             <a:avLst/>
@@ -5332,561 +5695,6 @@
                 <a:ea typeface="Helvetica Neue" panose="02000503000000020004" pitchFamily="2" charset="0"/>
                 <a:cs typeface="Helvetica Neue" panose="02000503000000020004" pitchFamily="2" charset="0"/>
               </a:rPr>
-              <a:t>Day 2 in more detail…</a:t>
-            </a:r>
-          </a:p>
-        </p:txBody>
-      </p:sp>
-    </p:spTree>
-    <p:extLst>
-      <p:ext uri="{BB962C8B-B14F-4D97-AF65-F5344CB8AC3E}">
-        <p14:creationId xmlns:p14="http://schemas.microsoft.com/office/powerpoint/2010/main" val="1030031058"/>
-      </p:ext>
-    </p:extLst>
-  </p:cSld>
-  <p:clrMapOvr>
-    <a:masterClrMapping/>
-  </p:clrMapOvr>
-</p:sld>
-</file>
-
-<file path=ppt/slides/slide4.xml><?xml version="1.0" encoding="utf-8"?>
-<p:sld xmlns:a="http://schemas.openxmlformats.org/drawingml/2006/main" xmlns:r="http://schemas.openxmlformats.org/officeDocument/2006/relationships" xmlns:p="http://schemas.openxmlformats.org/presentationml/2006/main">
-  <p:cSld>
-    <p:spTree>
-      <p:nvGrpSpPr>
-        <p:cNvPr id="1" name="">
-          <a:extLst>
-            <a:ext uri="{FF2B5EF4-FFF2-40B4-BE49-F238E27FC236}">
-              <a16:creationId xmlns:a16="http://schemas.microsoft.com/office/drawing/2014/main" id="{8821D57B-2310-A175-4DDC-EFA6941ABBB8}"/>
-            </a:ext>
-          </a:extLst>
-        </p:cNvPr>
-        <p:cNvGrpSpPr/>
-        <p:nvPr/>
-      </p:nvGrpSpPr>
-      <p:grpSpPr>
-        <a:xfrm>
-          <a:off x="0" y="0"/>
-          <a:ext cx="0" cy="0"/>
-          <a:chOff x="0" y="0"/>
-          <a:chExt cx="0" cy="0"/>
-        </a:xfrm>
-      </p:grpSpPr>
-      <p:pic>
-        <p:nvPicPr>
-          <p:cNvPr id="3" name="Picture 2">
-            <a:extLst>
-              <a:ext uri="{FF2B5EF4-FFF2-40B4-BE49-F238E27FC236}">
-                <a16:creationId xmlns:a16="http://schemas.microsoft.com/office/drawing/2014/main" id="{BB4FD7F7-B914-63E3-DDA6-5A360172C0DF}"/>
-              </a:ext>
-            </a:extLst>
-          </p:cNvPr>
-          <p:cNvPicPr>
-            <a:picLocks noChangeAspect="1"/>
-          </p:cNvPicPr>
-          <p:nvPr/>
-        </p:nvPicPr>
-        <p:blipFill>
-          <a:blip r:embed="rId2"/>
-          <a:stretch>
-            <a:fillRect/>
-          </a:stretch>
-        </p:blipFill>
-        <p:spPr>
-          <a:xfrm>
-            <a:off x="0" y="447139"/>
-            <a:ext cx="12151003" cy="5963722"/>
-          </a:xfrm>
-          <a:prstGeom prst="rect">
-            <a:avLst/>
-          </a:prstGeom>
-        </p:spPr>
-      </p:pic>
-      <p:sp>
-        <p:nvSpPr>
-          <p:cNvPr id="5" name="Rectangle 4">
-            <a:extLst>
-              <a:ext uri="{FF2B5EF4-FFF2-40B4-BE49-F238E27FC236}">
-                <a16:creationId xmlns:a16="http://schemas.microsoft.com/office/drawing/2014/main" id="{A762E375-D701-D242-3723-C41923A77C1D}"/>
-              </a:ext>
-            </a:extLst>
-          </p:cNvPr>
-          <p:cNvSpPr/>
-          <p:nvPr/>
-        </p:nvSpPr>
-        <p:spPr>
-          <a:xfrm>
-            <a:off x="7955280" y="1100153"/>
-            <a:ext cx="4000499" cy="4089067"/>
-          </a:xfrm>
-          <a:prstGeom prst="rect">
-            <a:avLst/>
-          </a:prstGeom>
-          <a:solidFill>
-            <a:srgbClr val="FFDFC2"/>
-          </a:solidFill>
-          <a:ln>
-            <a:noFill/>
-          </a:ln>
-        </p:spPr>
-        <p:style>
-          <a:lnRef idx="2">
-            <a:schemeClr val="accent1">
-              <a:shade val="15000"/>
-            </a:schemeClr>
-          </a:lnRef>
-          <a:fillRef idx="1">
-            <a:schemeClr val="accent1"/>
-          </a:fillRef>
-          <a:effectRef idx="0">
-            <a:schemeClr val="accent1"/>
-          </a:effectRef>
-          <a:fontRef idx="minor">
-            <a:schemeClr val="lt1"/>
-          </a:fontRef>
-        </p:style>
-        <p:txBody>
-          <a:bodyPr rtlCol="0" anchor="ctr"/>
-          <a:lstStyle/>
-          <a:p>
-            <a:pPr algn="ctr"/>
-            <a:endParaRPr lang="en-NL"/>
-          </a:p>
-        </p:txBody>
-      </p:sp>
-      <p:sp>
-        <p:nvSpPr>
-          <p:cNvPr id="7" name="Rectangle 6">
-            <a:extLst>
-              <a:ext uri="{FF2B5EF4-FFF2-40B4-BE49-F238E27FC236}">
-                <a16:creationId xmlns:a16="http://schemas.microsoft.com/office/drawing/2014/main" id="{09D97844-DE3A-9F95-A790-9666693DC8FC}"/>
-              </a:ext>
-            </a:extLst>
-          </p:cNvPr>
-          <p:cNvSpPr/>
-          <p:nvPr/>
-        </p:nvSpPr>
-        <p:spPr>
-          <a:xfrm>
-            <a:off x="4339591" y="3784550"/>
-            <a:ext cx="3505199" cy="1272540"/>
-          </a:xfrm>
-          <a:prstGeom prst="rect">
-            <a:avLst/>
-          </a:prstGeom>
-          <a:solidFill>
-            <a:srgbClr val="FFDFC2"/>
-          </a:solidFill>
-          <a:ln>
-            <a:noFill/>
-          </a:ln>
-        </p:spPr>
-        <p:style>
-          <a:lnRef idx="2">
-            <a:schemeClr val="accent1">
-              <a:shade val="15000"/>
-            </a:schemeClr>
-          </a:lnRef>
-          <a:fillRef idx="1">
-            <a:schemeClr val="accent1"/>
-          </a:fillRef>
-          <a:effectRef idx="0">
-            <a:schemeClr val="accent1"/>
-          </a:effectRef>
-          <a:fontRef idx="minor">
-            <a:schemeClr val="lt1"/>
-          </a:fontRef>
-        </p:style>
-        <p:txBody>
-          <a:bodyPr rtlCol="0" anchor="ctr"/>
-          <a:lstStyle/>
-          <a:p>
-            <a:pPr algn="ctr"/>
-            <a:endParaRPr lang="en-NL"/>
-          </a:p>
-        </p:txBody>
-      </p:sp>
-      <p:sp>
-        <p:nvSpPr>
-          <p:cNvPr id="8" name="Rectangle 7">
-            <a:extLst>
-              <a:ext uri="{FF2B5EF4-FFF2-40B4-BE49-F238E27FC236}">
-                <a16:creationId xmlns:a16="http://schemas.microsoft.com/office/drawing/2014/main" id="{97B4F196-CB14-BE00-CFE0-654E3364515D}"/>
-              </a:ext>
-            </a:extLst>
-          </p:cNvPr>
-          <p:cNvSpPr/>
-          <p:nvPr/>
-        </p:nvSpPr>
-        <p:spPr>
-          <a:xfrm>
-            <a:off x="2977516" y="4885640"/>
-            <a:ext cx="3505199" cy="1272540"/>
-          </a:xfrm>
-          <a:prstGeom prst="rect">
-            <a:avLst/>
-          </a:prstGeom>
-          <a:solidFill>
-            <a:srgbClr val="FFDFC2"/>
-          </a:solidFill>
-          <a:ln>
-            <a:noFill/>
-          </a:ln>
-        </p:spPr>
-        <p:style>
-          <a:lnRef idx="2">
-            <a:schemeClr val="accent1">
-              <a:shade val="15000"/>
-            </a:schemeClr>
-          </a:lnRef>
-          <a:fillRef idx="1">
-            <a:schemeClr val="accent1"/>
-          </a:fillRef>
-          <a:effectRef idx="0">
-            <a:schemeClr val="accent1"/>
-          </a:effectRef>
-          <a:fontRef idx="minor">
-            <a:schemeClr val="lt1"/>
-          </a:fontRef>
-        </p:style>
-        <p:txBody>
-          <a:bodyPr rtlCol="0" anchor="ctr"/>
-          <a:lstStyle/>
-          <a:p>
-            <a:pPr algn="ctr"/>
-            <a:endParaRPr lang="en-NL"/>
-          </a:p>
-        </p:txBody>
-      </p:sp>
-      <p:sp>
-        <p:nvSpPr>
-          <p:cNvPr id="2" name="Rectangle 1">
-            <a:extLst>
-              <a:ext uri="{FF2B5EF4-FFF2-40B4-BE49-F238E27FC236}">
-                <a16:creationId xmlns:a16="http://schemas.microsoft.com/office/drawing/2014/main" id="{A51D29ED-FE88-1F00-F83A-361AF52319F4}"/>
-              </a:ext>
-            </a:extLst>
-          </p:cNvPr>
-          <p:cNvSpPr/>
-          <p:nvPr/>
-        </p:nvSpPr>
-        <p:spPr>
-          <a:xfrm>
-            <a:off x="4229101" y="1199213"/>
-            <a:ext cx="3726180" cy="1132507"/>
-          </a:xfrm>
-          <a:prstGeom prst="rect">
-            <a:avLst/>
-          </a:prstGeom>
-          <a:solidFill>
-            <a:srgbClr val="FFDFC2"/>
-          </a:solidFill>
-          <a:ln>
-            <a:noFill/>
-          </a:ln>
-        </p:spPr>
-        <p:style>
-          <a:lnRef idx="2">
-            <a:schemeClr val="accent1">
-              <a:shade val="15000"/>
-            </a:schemeClr>
-          </a:lnRef>
-          <a:fillRef idx="1">
-            <a:schemeClr val="accent1"/>
-          </a:fillRef>
-          <a:effectRef idx="0">
-            <a:schemeClr val="accent1"/>
-          </a:effectRef>
-          <a:fontRef idx="minor">
-            <a:schemeClr val="lt1"/>
-          </a:fontRef>
-        </p:style>
-        <p:txBody>
-          <a:bodyPr rtlCol="0" anchor="ctr"/>
-          <a:lstStyle/>
-          <a:p>
-            <a:pPr algn="ctr"/>
-            <a:endParaRPr lang="en-NL"/>
-          </a:p>
-        </p:txBody>
-      </p:sp>
-    </p:spTree>
-    <p:extLst>
-      <p:ext uri="{BB962C8B-B14F-4D97-AF65-F5344CB8AC3E}">
-        <p14:creationId xmlns:p14="http://schemas.microsoft.com/office/powerpoint/2010/main" val="3597044244"/>
-      </p:ext>
-    </p:extLst>
-  </p:cSld>
-  <p:clrMapOvr>
-    <a:masterClrMapping/>
-  </p:clrMapOvr>
-</p:sld>
-</file>
-
-<file path=ppt/slides/slide5.xml><?xml version="1.0" encoding="utf-8"?>
-<p:sld xmlns:a="http://schemas.openxmlformats.org/drawingml/2006/main" xmlns:r="http://schemas.openxmlformats.org/officeDocument/2006/relationships" xmlns:p="http://schemas.openxmlformats.org/presentationml/2006/main">
-  <p:cSld>
-    <p:spTree>
-      <p:nvGrpSpPr>
-        <p:cNvPr id="1" name=""/>
-        <p:cNvGrpSpPr/>
-        <p:nvPr/>
-      </p:nvGrpSpPr>
-      <p:grpSpPr>
-        <a:xfrm>
-          <a:off x="0" y="0"/>
-          <a:ext cx="0" cy="0"/>
-          <a:chOff x="0" y="0"/>
-          <a:chExt cx="0" cy="0"/>
-        </a:xfrm>
-      </p:grpSpPr>
-      <p:pic>
-        <p:nvPicPr>
-          <p:cNvPr id="2050" name="Picture 2">
-            <a:extLst>
-              <a:ext uri="{FF2B5EF4-FFF2-40B4-BE49-F238E27FC236}">
-                <a16:creationId xmlns:a16="http://schemas.microsoft.com/office/drawing/2014/main" id="{574F2DDA-7547-B349-3A3D-99B14E877774}"/>
-              </a:ext>
-            </a:extLst>
-          </p:cNvPr>
-          <p:cNvPicPr>
-            <a:picLocks noChangeAspect="1" noChangeArrowheads="1"/>
-          </p:cNvPicPr>
-          <p:nvPr/>
-        </p:nvPicPr>
-        <p:blipFill>
-          <a:blip r:embed="rId2">
-            <a:extLst>
-              <a:ext uri="{28A0092B-C50C-407E-A947-70E740481C1C}">
-                <a14:useLocalDpi xmlns:a14="http://schemas.microsoft.com/office/drawing/2010/main" val="0"/>
-              </a:ext>
-            </a:extLst>
-          </a:blip>
-          <a:srcRect/>
-          <a:stretch>
-            <a:fillRect/>
-          </a:stretch>
-        </p:blipFill>
-        <p:spPr bwMode="auto">
-          <a:xfrm>
-            <a:off x="274320" y="1074420"/>
-            <a:ext cx="11132820" cy="5566410"/>
-          </a:xfrm>
-          <a:prstGeom prst="rect">
-            <a:avLst/>
-          </a:prstGeom>
-          <a:noFill/>
-          <a:extLst>
-            <a:ext uri="{909E8E84-426E-40DD-AFC4-6F175D3DCCD1}">
-              <a14:hiddenFill xmlns:a14="http://schemas.microsoft.com/office/drawing/2010/main">
-                <a:solidFill>
-                  <a:srgbClr val="FFFFFF"/>
-                </a:solidFill>
-              </a14:hiddenFill>
-            </a:ext>
-          </a:extLst>
-        </p:spPr>
-      </p:pic>
-      <p:sp>
-        <p:nvSpPr>
-          <p:cNvPr id="2" name="Content Placeholder 2">
-            <a:extLst>
-              <a:ext uri="{FF2B5EF4-FFF2-40B4-BE49-F238E27FC236}">
-                <a16:creationId xmlns:a16="http://schemas.microsoft.com/office/drawing/2014/main" id="{D47806BB-518C-F60B-C704-AB013DCEFF62}"/>
-              </a:ext>
-            </a:extLst>
-          </p:cNvPr>
-          <p:cNvSpPr txBox="1">
-            <a:spLocks/>
-          </p:cNvSpPr>
-          <p:nvPr/>
-        </p:nvSpPr>
-        <p:spPr>
-          <a:xfrm>
-            <a:off x="49530" y="217170"/>
-            <a:ext cx="10461962" cy="568288"/>
-          </a:xfrm>
-          <a:prstGeom prst="rect">
-            <a:avLst/>
-          </a:prstGeom>
-        </p:spPr>
-        <p:txBody>
-          <a:bodyPr/>
-          <a:lstStyle>
-            <a:lvl1pPr marL="228600" indent="-228600" algn="l" defTabSz="914400" rtl="0" eaLnBrk="1" latinLnBrk="0" hangingPunct="1">
-              <a:lnSpc>
-                <a:spcPct val="90000"/>
-              </a:lnSpc>
-              <a:spcBef>
-                <a:spcPts val="1000"/>
-              </a:spcBef>
-              <a:buFont typeface="Arial" panose="020B0604020202020204" pitchFamily="34" charset="0"/>
-              <a:buChar char="•"/>
-              <a:defRPr sz="2800" kern="1200">
-                <a:solidFill>
-                  <a:schemeClr val="tx1"/>
-                </a:solidFill>
-                <a:latin typeface="+mn-lt"/>
-                <a:ea typeface="+mn-ea"/>
-                <a:cs typeface="+mn-cs"/>
-              </a:defRPr>
-            </a:lvl1pPr>
-            <a:lvl2pPr marL="685800" indent="-228600" algn="l" defTabSz="914400" rtl="0" eaLnBrk="1" latinLnBrk="0" hangingPunct="1">
-              <a:lnSpc>
-                <a:spcPct val="90000"/>
-              </a:lnSpc>
-              <a:spcBef>
-                <a:spcPts val="500"/>
-              </a:spcBef>
-              <a:buFont typeface="Arial" panose="020B0604020202020204" pitchFamily="34" charset="0"/>
-              <a:buChar char="•"/>
-              <a:defRPr sz="2400" kern="1200">
-                <a:solidFill>
-                  <a:schemeClr val="tx1"/>
-                </a:solidFill>
-                <a:latin typeface="+mn-lt"/>
-                <a:ea typeface="+mn-ea"/>
-                <a:cs typeface="+mn-cs"/>
-              </a:defRPr>
-            </a:lvl2pPr>
-            <a:lvl3pPr marL="1143000" indent="-228600" algn="l" defTabSz="914400" rtl="0" eaLnBrk="1" latinLnBrk="0" hangingPunct="1">
-              <a:lnSpc>
-                <a:spcPct val="90000"/>
-              </a:lnSpc>
-              <a:spcBef>
-                <a:spcPts val="500"/>
-              </a:spcBef>
-              <a:buFont typeface="Arial" panose="020B0604020202020204" pitchFamily="34" charset="0"/>
-              <a:buChar char="•"/>
-              <a:defRPr sz="2000" kern="1200">
-                <a:solidFill>
-                  <a:schemeClr val="tx1"/>
-                </a:solidFill>
-                <a:latin typeface="+mn-lt"/>
-                <a:ea typeface="+mn-ea"/>
-                <a:cs typeface="+mn-cs"/>
-              </a:defRPr>
-            </a:lvl3pPr>
-            <a:lvl4pPr marL="1600200" indent="-228600" algn="l" defTabSz="914400" rtl="0" eaLnBrk="1" latinLnBrk="0" hangingPunct="1">
-              <a:lnSpc>
-                <a:spcPct val="90000"/>
-              </a:lnSpc>
-              <a:spcBef>
-                <a:spcPts val="500"/>
-              </a:spcBef>
-              <a:buFont typeface="Arial" panose="020B0604020202020204" pitchFamily="34" charset="0"/>
-              <a:buChar char="•"/>
-              <a:defRPr sz="1800" kern="1200">
-                <a:solidFill>
-                  <a:schemeClr val="tx1"/>
-                </a:solidFill>
-                <a:latin typeface="+mn-lt"/>
-                <a:ea typeface="+mn-ea"/>
-                <a:cs typeface="+mn-cs"/>
-              </a:defRPr>
-            </a:lvl4pPr>
-            <a:lvl5pPr marL="2057400" indent="-228600" algn="l" defTabSz="914400" rtl="0" eaLnBrk="1" latinLnBrk="0" hangingPunct="1">
-              <a:lnSpc>
-                <a:spcPct val="90000"/>
-              </a:lnSpc>
-              <a:spcBef>
-                <a:spcPts val="500"/>
-              </a:spcBef>
-              <a:buFont typeface="Arial" panose="020B0604020202020204" pitchFamily="34" charset="0"/>
-              <a:buChar char="•"/>
-              <a:defRPr sz="1800" kern="1200">
-                <a:solidFill>
-                  <a:schemeClr val="tx1"/>
-                </a:solidFill>
-                <a:latin typeface="+mn-lt"/>
-                <a:ea typeface="+mn-ea"/>
-                <a:cs typeface="+mn-cs"/>
-              </a:defRPr>
-            </a:lvl5pPr>
-            <a:lvl6pPr marL="2514600" indent="-228600" algn="l" defTabSz="914400" rtl="0" eaLnBrk="1" latinLnBrk="0" hangingPunct="1">
-              <a:lnSpc>
-                <a:spcPct val="90000"/>
-              </a:lnSpc>
-              <a:spcBef>
-                <a:spcPts val="500"/>
-              </a:spcBef>
-              <a:buFont typeface="Arial" panose="020B0604020202020204" pitchFamily="34" charset="0"/>
-              <a:buChar char="•"/>
-              <a:defRPr sz="1800" kern="1200">
-                <a:solidFill>
-                  <a:schemeClr val="tx1"/>
-                </a:solidFill>
-                <a:latin typeface="+mn-lt"/>
-                <a:ea typeface="+mn-ea"/>
-                <a:cs typeface="+mn-cs"/>
-              </a:defRPr>
-            </a:lvl6pPr>
-            <a:lvl7pPr marL="2971800" indent="-228600" algn="l" defTabSz="914400" rtl="0" eaLnBrk="1" latinLnBrk="0" hangingPunct="1">
-              <a:lnSpc>
-                <a:spcPct val="90000"/>
-              </a:lnSpc>
-              <a:spcBef>
-                <a:spcPts val="500"/>
-              </a:spcBef>
-              <a:buFont typeface="Arial" panose="020B0604020202020204" pitchFamily="34" charset="0"/>
-              <a:buChar char="•"/>
-              <a:defRPr sz="1800" kern="1200">
-                <a:solidFill>
-                  <a:schemeClr val="tx1"/>
-                </a:solidFill>
-                <a:latin typeface="+mn-lt"/>
-                <a:ea typeface="+mn-ea"/>
-                <a:cs typeface="+mn-cs"/>
-              </a:defRPr>
-            </a:lvl7pPr>
-            <a:lvl8pPr marL="3429000" indent="-228600" algn="l" defTabSz="914400" rtl="0" eaLnBrk="1" latinLnBrk="0" hangingPunct="1">
-              <a:lnSpc>
-                <a:spcPct val="90000"/>
-              </a:lnSpc>
-              <a:spcBef>
-                <a:spcPts val="500"/>
-              </a:spcBef>
-              <a:buFont typeface="Arial" panose="020B0604020202020204" pitchFamily="34" charset="0"/>
-              <a:buChar char="•"/>
-              <a:defRPr sz="1800" kern="1200">
-                <a:solidFill>
-                  <a:schemeClr val="tx1"/>
-                </a:solidFill>
-                <a:latin typeface="+mn-lt"/>
-                <a:ea typeface="+mn-ea"/>
-                <a:cs typeface="+mn-cs"/>
-              </a:defRPr>
-            </a:lvl8pPr>
-            <a:lvl9pPr marL="3886200" indent="-228600" algn="l" defTabSz="914400" rtl="0" eaLnBrk="1" latinLnBrk="0" hangingPunct="1">
-              <a:lnSpc>
-                <a:spcPct val="90000"/>
-              </a:lnSpc>
-              <a:spcBef>
-                <a:spcPts val="500"/>
-              </a:spcBef>
-              <a:buFont typeface="Arial" panose="020B0604020202020204" pitchFamily="34" charset="0"/>
-              <a:buChar char="•"/>
-              <a:defRPr sz="1800" kern="1200">
-                <a:solidFill>
-                  <a:schemeClr val="tx1"/>
-                </a:solidFill>
-                <a:latin typeface="+mn-lt"/>
-                <a:ea typeface="+mn-ea"/>
-                <a:cs typeface="+mn-cs"/>
-              </a:defRPr>
-            </a:lvl9pPr>
-          </a:lstStyle>
-          <a:p>
-            <a:pPr marL="0" indent="0" algn="ctr">
-              <a:buNone/>
-            </a:pPr>
-            <a:r>
-              <a:rPr lang="en-NL" b="1" dirty="0">
-                <a:latin typeface="Helvetica Neue" panose="02000503000000020004" pitchFamily="2" charset="0"/>
-                <a:ea typeface="Helvetica Neue" panose="02000503000000020004" pitchFamily="2" charset="0"/>
-                <a:cs typeface="Helvetica Neue" panose="02000503000000020004" pitchFamily="2" charset="0"/>
-              </a:rPr>
               <a:t>Plotting the effect of variance stabilizing transformation:</a:t>
             </a:r>
           </a:p>
@@ -6749,6 +6557,126 @@
   <p:clrMapOvr>
     <a:masterClrMapping/>
   </p:clrMapOvr>
+  <p:timing>
+    <p:tnLst>
+      <p:par>
+        <p:cTn id="1" dur="indefinite" restart="never" nodeType="tmRoot">
+          <p:childTnLst>
+            <p:seq concurrent="1" nextAc="seek">
+              <p:cTn id="2" dur="indefinite" nodeType="mainSeq">
+                <p:childTnLst>
+                  <p:par>
+                    <p:cTn id="3" fill="hold">
+                      <p:stCondLst>
+                        <p:cond delay="indefinite"/>
+                      </p:stCondLst>
+                      <p:childTnLst>
+                        <p:par>
+                          <p:cTn id="4" fill="hold">
+                            <p:stCondLst>
+                              <p:cond delay="0"/>
+                            </p:stCondLst>
+                            <p:childTnLst>
+                              <p:par>
+                                <p:cTn id="5" presetID="1" presetClass="entr" presetSubtype="0" fill="hold" nodeType="clickEffect">
+                                  <p:stCondLst>
+                                    <p:cond delay="0"/>
+                                  </p:stCondLst>
+                                  <p:childTnLst>
+                                    <p:set>
+                                      <p:cBhvr>
+                                        <p:cTn id="6" dur="1" fill="hold">
+                                          <p:stCondLst>
+                                            <p:cond delay="0"/>
+                                          </p:stCondLst>
+                                        </p:cTn>
+                                        <p:tgtEl>
+                                          <p:spTgt spid="6"/>
+                                        </p:tgtEl>
+                                        <p:attrNameLst>
+                                          <p:attrName>style.visibility</p:attrName>
+                                        </p:attrNameLst>
+                                      </p:cBhvr>
+                                      <p:to>
+                                        <p:strVal val="visible"/>
+                                      </p:to>
+                                    </p:set>
+                                  </p:childTnLst>
+                                </p:cTn>
+                              </p:par>
+                            </p:childTnLst>
+                          </p:cTn>
+                        </p:par>
+                      </p:childTnLst>
+                    </p:cTn>
+                  </p:par>
+                  <p:par>
+                    <p:cTn id="7" fill="hold">
+                      <p:stCondLst>
+                        <p:cond delay="indefinite"/>
+                      </p:stCondLst>
+                      <p:childTnLst>
+                        <p:par>
+                          <p:cTn id="8" fill="hold">
+                            <p:stCondLst>
+                              <p:cond delay="0"/>
+                            </p:stCondLst>
+                            <p:childTnLst>
+                              <p:par>
+                                <p:cTn id="9" presetID="1" presetClass="entr" presetSubtype="0" fill="hold" nodeType="clickEffect">
+                                  <p:stCondLst>
+                                    <p:cond delay="0"/>
+                                  </p:stCondLst>
+                                  <p:childTnLst>
+                                    <p:set>
+                                      <p:cBhvr>
+                                        <p:cTn id="10" dur="1" fill="hold">
+                                          <p:stCondLst>
+                                            <p:cond delay="0"/>
+                                          </p:stCondLst>
+                                        </p:cTn>
+                                        <p:tgtEl>
+                                          <p:spTgt spid="9"/>
+                                        </p:tgtEl>
+                                        <p:attrNameLst>
+                                          <p:attrName>style.visibility</p:attrName>
+                                        </p:attrNameLst>
+                                      </p:cBhvr>
+                                      <p:to>
+                                        <p:strVal val="visible"/>
+                                      </p:to>
+                                    </p:set>
+                                  </p:childTnLst>
+                                </p:cTn>
+                              </p:par>
+                            </p:childTnLst>
+                          </p:cTn>
+                        </p:par>
+                      </p:childTnLst>
+                    </p:cTn>
+                  </p:par>
+                </p:childTnLst>
+              </p:cTn>
+              <p:prevCondLst>
+                <p:cond evt="onPrev" delay="0">
+                  <p:tgtEl>
+                    <p:sldTgt/>
+                  </p:tgtEl>
+                </p:cond>
+              </p:prevCondLst>
+              <p:nextCondLst>
+                <p:cond evt="onNext" delay="0">
+                  <p:tgtEl>
+                    <p:sldTgt/>
+                  </p:tgtEl>
+                </p:cond>
+              </p:nextCondLst>
+            </p:seq>
+          </p:childTnLst>
+        </p:cTn>
+      </p:par>
+    </p:tnLst>
+  </p:timing>
 </p:sld>
 </file>
 

</xml_diff>